<commit_message>
Drop emoji from the G1-B deck and add the review-meeting agenda
Slide 8 (the journey map) was unreadable: TH Sarabun New has no glyphs for
emoji, so PowerPoint fell back mid-run and mangled the Thai around them.
Emotions are now words plus a plain (+)/(0)/(-) marker, cell text is shorter,
and the table font goes from 10.5pt to 12.5pt.

g1-b-problem-statement.md gains an agenda section for the 10 Sep team review:
the three decisions that have to be settled there (how a "return" is defined,
which customer group the problem statement targets and what "silent" means in
days, and how to talk about the returns/churn correlation), each with options
and consequences.

Co-Authored-By: Claude Opus 5 <noreply@anthropic.com>
</commit_message>
<xml_diff>
--- a/slides/G1-B-slides.pptx
+++ b/slides/G1-B-slides.pptx
@@ -2643,7 +2643,7 @@
                 <a:ea typeface="TH Sarabun New" pitchFamily="34" charset="-122"/>
                 <a:cs typeface="TH Sarabun New" pitchFamily="34" charset="-120"/>
               </a:rPr>
-              <a:t>❌ FEEDBACK LOOP ที่ขาด — </a:t>
+              <a:t>FEEDBACK LOOP ที่ขาด — </a:t>
             </a:r>
             <a:pPr indent="0" marL="0">
               <a:buNone/>
@@ -11216,21 +11216,21 @@
         </p:nvGraphicFramePr>
         <p:xfrm>
           <a:off x="411480" y="1463040"/>
-          <a:ext cx="11384280" cy="3931920"/>
+          <a:ext cx="11384280" cy="3977640"/>
         </p:xfrm>
         <a:graphic>
           <a:graphicData uri="http://schemas.openxmlformats.org/drawingml/2006/table">
             <a:tbl>
               <a:tblPr/>
               <a:tblGrid>
-                <a:gridCol w="1234440"/>
-                <a:gridCol w="2029968"/>
-                <a:gridCol w="2029968"/>
-                <a:gridCol w="2029968"/>
-                <a:gridCol w="2029968"/>
-                <a:gridCol w="2029968"/>
+                <a:gridCol w="1325880"/>
+                <a:gridCol w="2011680"/>
+                <a:gridCol w="2011680"/>
+                <a:gridCol w="2011680"/>
+                <a:gridCol w="2011680"/>
+                <a:gridCol w="2011680"/>
               </a:tblGrid>
-              <a:tr h="561703">
+              <a:tr h="566928">
                 <a:tc>
                   <a:txBody>
                     <a:bodyPr/>
@@ -11240,7 +11240,7 @@
                         <a:buNone/>
                       </a:pPr>
                       <a:r>
-                        <a:rPr lang="en-US" sz="1150" b="1" dirty="0">
+                        <a:rPr lang="en-US" sz="1250" b="1" dirty="0">
                           <a:solidFill>
                             <a:srgbClr val="FFFFFF"/>
                           </a:solidFill>
@@ -11250,7 +11250,7 @@
                         </a:rPr>
                         <a:t>STAGE</a:t>
                       </a:r>
-                      <a:endParaRPr lang="en-US" sz="1150" dirty="0">
+                      <a:endParaRPr lang="en-US" sz="1250" dirty="0">
                         <a:latin typeface="TH Sarabun New" charset="0"/>
                         <a:ea typeface="TH Sarabun New" charset="0"/>
                         <a:cs typeface="TH Sarabun New" charset="0"/>
@@ -11308,7 +11308,7 @@
                         <a:buNone/>
                       </a:pPr>
                       <a:r>
-                        <a:rPr lang="en-US" sz="1150" b="1" dirty="0">
+                        <a:rPr lang="en-US" sz="1250" b="1" dirty="0">
                           <a:solidFill>
                             <a:srgbClr val="FFFFFF"/>
                           </a:solidFill>
@@ -11318,7 +11318,7 @@
                         </a:rPr>
                         <a:t>1. รู้จัก &amp; สั่งครั้งแรก</a:t>
                       </a:r>
-                      <a:endParaRPr lang="en-US" sz="1150" dirty="0">
+                      <a:endParaRPr lang="en-US" sz="1250" dirty="0">
                         <a:latin typeface="TH Sarabun New" charset="0"/>
                         <a:ea typeface="TH Sarabun New" charset="0"/>
                         <a:cs typeface="TH Sarabun New" charset="0"/>
@@ -11376,7 +11376,7 @@
                         <a:buNone/>
                       </a:pPr>
                       <a:r>
-                        <a:rPr lang="en-US" sz="1150" b="1" dirty="0">
+                        <a:rPr lang="en-US" sz="1250" b="1" dirty="0">
                           <a:solidFill>
                             <a:srgbClr val="FFFFFF"/>
                           </a:solidFill>
@@ -11386,7 +11386,7 @@
                         </a:rPr>
                         <a:t>2. รับของครั้งแรก</a:t>
                       </a:r>
-                      <a:endParaRPr lang="en-US" sz="1150" dirty="0">
+                      <a:endParaRPr lang="en-US" sz="1250" dirty="0">
                         <a:latin typeface="TH Sarabun New" charset="0"/>
                         <a:ea typeface="TH Sarabun New" charset="0"/>
                         <a:cs typeface="TH Sarabun New" charset="0"/>
@@ -11444,7 +11444,7 @@
                         <a:buNone/>
                       </a:pPr>
                       <a:r>
-                        <a:rPr lang="en-US" sz="1150" b="1" dirty="0">
+                        <a:rPr lang="en-US" sz="1250" b="1" dirty="0">
                           <a:solidFill>
                             <a:srgbClr val="FFFFFF"/>
                           </a:solidFill>
@@ -11454,7 +11454,7 @@
                         </a:rPr>
                         <a:t>3. กลับมาซื้อซ้ำ</a:t>
                       </a:r>
-                      <a:endParaRPr lang="en-US" sz="1150" dirty="0">
+                      <a:endParaRPr lang="en-US" sz="1250" dirty="0">
                         <a:latin typeface="TH Sarabun New" charset="0"/>
                         <a:ea typeface="TH Sarabun New" charset="0"/>
                         <a:cs typeface="TH Sarabun New" charset="0"/>
@@ -11512,7 +11512,7 @@
                         <a:buNone/>
                       </a:pPr>
                       <a:r>
-                        <a:rPr lang="en-US" sz="1150" b="1" dirty="0">
+                        <a:rPr lang="en-US" sz="1250" b="1" dirty="0">
                           <a:solidFill>
                             <a:srgbClr val="FFFFFF"/>
                           </a:solidFill>
@@ -11522,7 +11522,7 @@
                         </a:rPr>
                         <a:t>4. คืนของ / มีปัญหา</a:t>
                       </a:r>
-                      <a:endParaRPr lang="en-US" sz="1150" dirty="0">
+                      <a:endParaRPr lang="en-US" sz="1250" dirty="0">
                         <a:latin typeface="TH Sarabun New" charset="0"/>
                         <a:ea typeface="TH Sarabun New" charset="0"/>
                         <a:cs typeface="TH Sarabun New" charset="0"/>
@@ -11580,9 +11580,9 @@
                         <a:buNone/>
                       </a:pPr>
                       <a:r>
-                        <a:rPr lang="en-US" sz="1150" b="1" dirty="0">
+                        <a:rPr lang="en-US" sz="1250" b="1" dirty="0">
                           <a:solidFill>
-                            <a:srgbClr val="FFD9D2"/>
+                            <a:srgbClr val="FFFFFF"/>
                           </a:solidFill>
                           <a:latin typeface="TH Sarabun New" pitchFamily="34" charset="0"/>
                           <a:ea typeface="TH Sarabun New" pitchFamily="34" charset="-122"/>
@@ -11590,7 +11590,7 @@
                         </a:rPr>
                         <a:t>5. เงียบหาย</a:t>
                       </a:r>
-                      <a:endParaRPr lang="en-US" sz="1150" dirty="0">
+                      <a:endParaRPr lang="en-US" sz="1250" dirty="0">
                         <a:latin typeface="TH Sarabun New" charset="0"/>
                         <a:ea typeface="TH Sarabun New" charset="0"/>
                         <a:cs typeface="TH Sarabun New" charset="0"/>
@@ -11640,7 +11640,7 @@
                   </a:tcPr>
                 </a:tc>
               </a:tr>
-              <a:tr h="561703">
+              <a:tr h="566928">
                 <a:tc>
                   <a:txBody>
                     <a:bodyPr/>
@@ -11650,7 +11650,7 @@
                         <a:buNone/>
                       </a:pPr>
                       <a:r>
-                        <a:rPr lang="en-US" sz="1100" b="1" dirty="0">
+                        <a:rPr lang="en-US" sz="1200" b="1" dirty="0">
                           <a:solidFill>
                             <a:srgbClr val="1E2761"/>
                           </a:solidFill>
@@ -11660,7 +11660,7 @@
                         </a:rPr>
                         <a:t>STEPS</a:t>
                       </a:r>
-                      <a:endParaRPr lang="en-US" sz="1100" dirty="0">
+                      <a:endParaRPr lang="en-US" sz="1200" dirty="0">
                         <a:latin typeface="TH Sarabun New" charset="0"/>
                         <a:ea typeface="TH Sarabun New" charset="0"/>
                         <a:cs typeface="TH Sarabun New" charset="0"/>
@@ -11718,17 +11718,17 @@
                         <a:buNone/>
                       </a:pPr>
                       <a:r>
-                        <a:rPr lang="en-US" sz="1050" dirty="0">
+                        <a:rPr lang="en-US" sz="1250" dirty="0">
                           <a:solidFill>
-                            <a:srgbClr val="5B6B8C"/>
+                            <a:srgbClr val="1E2761"/>
                           </a:solidFill>
                           <a:latin typeface="TH Sarabun New" pitchFamily="34" charset="0"/>
                           <a:ea typeface="TH Sarabun New" pitchFamily="34" charset="-122"/>
                           <a:cs typeface="TH Sarabun New" pitchFamily="34" charset="-120"/>
                         </a:rPr>
-                        <a:t>เลือกสินค้า → สั่งซื้อ → ออกใบแจ้งหนี้</a:t>
+                        <a:t>เลือกสินค้า → สั่งซื้อ</a:t>
                       </a:r>
-                      <a:endParaRPr lang="en-US" sz="1050" dirty="0">
+                      <a:endParaRPr lang="en-US" sz="1250" dirty="0">
                         <a:latin typeface="TH Sarabun New" charset="0"/>
                         <a:ea typeface="TH Sarabun New" charset="0"/>
                         <a:cs typeface="TH Sarabun New" charset="0"/>
@@ -11786,9 +11786,9 @@
                         <a:buNone/>
                       </a:pPr>
                       <a:r>
-                        <a:rPr lang="en-US" sz="1050" dirty="0">
+                        <a:rPr lang="en-US" sz="1250" dirty="0">
                           <a:solidFill>
-                            <a:srgbClr val="5B6B8C"/>
+                            <a:srgbClr val="1E2761"/>
                           </a:solidFill>
                           <a:latin typeface="TH Sarabun New" pitchFamily="34" charset="0"/>
                           <a:ea typeface="TH Sarabun New" pitchFamily="34" charset="-122"/>
@@ -11796,7 +11796,7 @@
                         </a:rPr>
                         <a:t>รับของ → ตรวจของ</a:t>
                       </a:r>
-                      <a:endParaRPr lang="en-US" sz="1050" dirty="0">
+                      <a:endParaRPr lang="en-US" sz="1250" dirty="0">
                         <a:latin typeface="TH Sarabun New" charset="0"/>
                         <a:ea typeface="TH Sarabun New" charset="0"/>
                         <a:cs typeface="TH Sarabun New" charset="0"/>
@@ -11854,17 +11854,38 @@
                         <a:buNone/>
                       </a:pPr>
                       <a:r>
-                        <a:rPr lang="en-US" sz="1050" dirty="0">
+                        <a:rPr lang="en-US" sz="1250" dirty="0">
                           <a:solidFill>
-                            <a:srgbClr val="5B6B8C"/>
+                            <a:srgbClr val="1E2761"/>
                           </a:solidFill>
                           <a:latin typeface="TH Sarabun New" pitchFamily="34" charset="0"/>
                           <a:ea typeface="TH Sarabun New" pitchFamily="34" charset="-122"/>
                           <a:cs typeface="TH Sarabun New" pitchFamily="34" charset="-120"/>
                         </a:rPr>
-                        <a:t>สั่งรอบถัดไป (มัธยฐาน 56 วัน)</a:t>
+                        <a:t>สั่งรอบถัดไป</a:t>
                       </a:r>
-                      <a:endParaRPr lang="en-US" sz="1050" dirty="0">
+                      <a:endParaRPr lang="en-US" sz="1250" dirty="0">
+                        <a:latin typeface="TH Sarabun New" charset="0"/>
+                        <a:ea typeface="TH Sarabun New" charset="0"/>
+                        <a:cs typeface="TH Sarabun New" charset="0"/>
+                      </a:endParaRPr>
+                    </a:p>
+                    <a:p>
+                      <a:pPr algn="l" indent="0" marL="0">
+                        <a:buNone/>
+                      </a:pPr>
+                      <a:r>
+                        <a:rPr lang="en-US" sz="1250" dirty="0">
+                          <a:solidFill>
+                            <a:srgbClr val="1E2761"/>
+                          </a:solidFill>
+                          <a:latin typeface="TH Sarabun New" pitchFamily="34" charset="0"/>
+                          <a:ea typeface="TH Sarabun New" pitchFamily="34" charset="-122"/>
+                          <a:cs typeface="TH Sarabun New" pitchFamily="34" charset="-120"/>
+                        </a:rPr>
+                        <a:t>(มัธยฐาน 56 วัน)</a:t>
+                      </a:r>
+                      <a:endParaRPr lang="en-US" sz="1250" dirty="0">
                         <a:latin typeface="TH Sarabun New" charset="0"/>
                         <a:ea typeface="TH Sarabun New" charset="0"/>
                         <a:cs typeface="TH Sarabun New" charset="0"/>
@@ -11922,17 +11943,17 @@
                         <a:buNone/>
                       </a:pPr>
                       <a:r>
-                        <a:rPr lang="en-US" sz="1050" dirty="0">
+                        <a:rPr lang="en-US" sz="1250" dirty="0">
                           <a:solidFill>
-                            <a:srgbClr val="5B6B8C"/>
+                            <a:srgbClr val="1E2761"/>
                           </a:solidFill>
                           <a:latin typeface="TH Sarabun New" pitchFamily="34" charset="0"/>
                           <a:ea typeface="TH Sarabun New" pitchFamily="34" charset="-122"/>
                           <a:cs typeface="TH Sarabun New" pitchFamily="34" charset="-120"/>
                         </a:rPr>
-                        <a:t>แจ้งคืน → ออกใบ C → คืนเงิน</a:t>
+                        <a:t>แจ้งคืน → ออกใบ C</a:t>
                       </a:r>
-                      <a:endParaRPr lang="en-US" sz="1050" dirty="0">
+                      <a:endParaRPr lang="en-US" sz="1250" dirty="0">
                         <a:latin typeface="TH Sarabun New" charset="0"/>
                         <a:ea typeface="TH Sarabun New" charset="0"/>
                         <a:cs typeface="TH Sarabun New" charset="0"/>
@@ -11990,7 +12011,7 @@
                         <a:buNone/>
                       </a:pPr>
                       <a:r>
-                        <a:rPr lang="en-US" sz="1050" dirty="0">
+                        <a:rPr lang="en-US" sz="1250" dirty="0">
                           <a:solidFill>
                             <a:srgbClr val="B3402F"/>
                           </a:solidFill>
@@ -12000,7 +12021,7 @@
                         </a:rPr>
                         <a:t>ไม่มีคำสั่งซื้ออีก</a:t>
                       </a:r>
-                      <a:endParaRPr lang="en-US" sz="1050" dirty="0">
+                      <a:endParaRPr lang="en-US" sz="1250" dirty="0">
                         <a:latin typeface="TH Sarabun New" charset="0"/>
                         <a:ea typeface="TH Sarabun New" charset="0"/>
                         <a:cs typeface="TH Sarabun New" charset="0"/>
@@ -12050,7 +12071,7 @@
                   </a:tcPr>
                 </a:tc>
               </a:tr>
-              <a:tr h="561703">
+              <a:tr h="566928">
                 <a:tc>
                   <a:txBody>
                     <a:bodyPr/>
@@ -12060,7 +12081,7 @@
                         <a:buNone/>
                       </a:pPr>
                       <a:r>
-                        <a:rPr lang="en-US" sz="1100" b="1" dirty="0">
+                        <a:rPr lang="en-US" sz="1200" b="1" dirty="0">
                           <a:solidFill>
                             <a:srgbClr val="1E2761"/>
                           </a:solidFill>
@@ -12070,7 +12091,7 @@
                         </a:rPr>
                         <a:t>THOUGHTS</a:t>
                       </a:r>
-                      <a:endParaRPr lang="en-US" sz="1100" dirty="0">
+                      <a:endParaRPr lang="en-US" sz="1200" dirty="0">
                         <a:latin typeface="TH Sarabun New" charset="0"/>
                         <a:ea typeface="TH Sarabun New" charset="0"/>
                         <a:cs typeface="TH Sarabun New" charset="0"/>
@@ -12128,17 +12149,17 @@
                         <a:buNone/>
                       </a:pPr>
                       <a:r>
-                        <a:rPr lang="en-US" sz="1050" dirty="0">
+                        <a:rPr lang="en-US" sz="1250" dirty="0">
                           <a:solidFill>
-                            <a:srgbClr val="5B6B8C"/>
+                            <a:srgbClr val="1E2761"/>
                           </a:solidFill>
                           <a:latin typeface="TH Sarabun New" pitchFamily="34" charset="0"/>
                           <a:ea typeface="TH Sarabun New" pitchFamily="34" charset="-122"/>
                           <a:cs typeface="TH Sarabun New" pitchFamily="34" charset="-120"/>
                         </a:rPr>
-                        <a:t>“ราคาโอเค ลองสั่งดูก่อน”</a:t>
+                        <a:t>ราคาโอเค ลองสั่งดู</a:t>
                       </a:r>
-                      <a:endParaRPr lang="en-US" sz="1050" dirty="0">
+                      <a:endParaRPr lang="en-US" sz="1250" dirty="0">
                         <a:latin typeface="TH Sarabun New" charset="0"/>
                         <a:ea typeface="TH Sarabun New" charset="0"/>
                         <a:cs typeface="TH Sarabun New" charset="0"/>
@@ -12196,17 +12217,17 @@
                         <a:buNone/>
                       </a:pPr>
                       <a:r>
-                        <a:rPr lang="en-US" sz="1050" dirty="0">
+                        <a:rPr lang="en-US" sz="1250" dirty="0">
                           <a:solidFill>
-                            <a:srgbClr val="5B6B8C"/>
+                            <a:srgbClr val="1E2761"/>
                           </a:solidFill>
                           <a:latin typeface="TH Sarabun New" pitchFamily="34" charset="0"/>
                           <a:ea typeface="TH Sarabun New" pitchFamily="34" charset="-122"/>
                           <a:cs typeface="TH Sarabun New" pitchFamily="34" charset="-120"/>
                         </a:rPr>
-                        <a:t>“ของครบมั้ย ตรงรูปมั้ย”</a:t>
+                        <a:t>ของครบมั้ย ตรงรูปมั้ย</a:t>
                       </a:r>
-                      <a:endParaRPr lang="en-US" sz="1050" dirty="0">
+                      <a:endParaRPr lang="en-US" sz="1250" dirty="0">
                         <a:latin typeface="TH Sarabun New" charset="0"/>
                         <a:ea typeface="TH Sarabun New" charset="0"/>
                         <a:cs typeface="TH Sarabun New" charset="0"/>
@@ -12264,17 +12285,17 @@
                         <a:buNone/>
                       </a:pPr>
                       <a:r>
-                        <a:rPr lang="en-US" sz="1050" dirty="0">
+                        <a:rPr lang="en-US" sz="1250" dirty="0">
                           <a:solidFill>
-                            <a:srgbClr val="5B6B8C"/>
+                            <a:srgbClr val="1E2761"/>
                           </a:solidFill>
                           <a:latin typeface="TH Sarabun New" pitchFamily="34" charset="0"/>
                           <a:ea typeface="TH Sarabun New" pitchFamily="34" charset="-122"/>
                           <a:cs typeface="TH Sarabun New" pitchFamily="34" charset="-120"/>
                         </a:rPr>
-                        <a:t>“เจ้านี้ใช้ได้ สั่งเพิ่มเลย”</a:t>
+                        <a:t>เจ้านี้ใช้ได้ สั่งเพิ่ม</a:t>
                       </a:r>
-                      <a:endParaRPr lang="en-US" sz="1050" dirty="0">
+                      <a:endParaRPr lang="en-US" sz="1250" dirty="0">
                         <a:latin typeface="TH Sarabun New" charset="0"/>
                         <a:ea typeface="TH Sarabun New" charset="0"/>
                         <a:cs typeface="TH Sarabun New" charset="0"/>
@@ -12332,17 +12353,17 @@
                         <a:buNone/>
                       </a:pPr>
                       <a:r>
-                        <a:rPr lang="en-US" sz="1050" dirty="0">
+                        <a:rPr lang="en-US" sz="1250" dirty="0">
                           <a:solidFill>
-                            <a:srgbClr val="5B6B8C"/>
+                            <a:srgbClr val="1E2761"/>
                           </a:solidFill>
                           <a:latin typeface="TH Sarabun New" pitchFamily="34" charset="0"/>
                           <a:ea typeface="TH Sarabun New" pitchFamily="34" charset="-122"/>
                           <a:cs typeface="TH Sarabun New" pitchFamily="34" charset="-120"/>
                         </a:rPr>
-                        <a:t>“ของไม่ครบ/พัง ต้องแจ้งใคร”</a:t>
+                        <a:t>ของพัง ต้องแจ้งใคร</a:t>
                       </a:r>
-                      <a:endParaRPr lang="en-US" sz="1050" dirty="0">
+                      <a:endParaRPr lang="en-US" sz="1250" dirty="0">
                         <a:latin typeface="TH Sarabun New" charset="0"/>
                         <a:ea typeface="TH Sarabun New" charset="0"/>
                         <a:cs typeface="TH Sarabun New" charset="0"/>
@@ -12400,7 +12421,7 @@
                         <a:buNone/>
                       </a:pPr>
                       <a:r>
-                        <a:rPr lang="en-US" sz="1050" dirty="0">
+                        <a:rPr lang="en-US" sz="1250" dirty="0">
                           <a:solidFill>
                             <a:srgbClr val="B3402F"/>
                           </a:solidFill>
@@ -12408,9 +12429,9 @@
                           <a:ea typeface="TH Sarabun New" pitchFamily="34" charset="-122"/>
                           <a:cs typeface="TH Sarabun New" pitchFamily="34" charset="-120"/>
                         </a:rPr>
-                        <a:t>(ไม่มีเสียง — ลูกค้าไม่บอกลา)</a:t>
+                        <a:t>ไม่มีเสียง — ลูกค้าไม่บอกลา</a:t>
                       </a:r>
-                      <a:endParaRPr lang="en-US" sz="1050" dirty="0">
+                      <a:endParaRPr lang="en-US" sz="1250" dirty="0">
                         <a:latin typeface="TH Sarabun New" charset="0"/>
                         <a:ea typeface="TH Sarabun New" charset="0"/>
                         <a:cs typeface="TH Sarabun New" charset="0"/>
@@ -12460,7 +12481,7 @@
                   </a:tcPr>
                 </a:tc>
               </a:tr>
-              <a:tr h="561703">
+              <a:tr h="566928">
                 <a:tc>
                   <a:txBody>
                     <a:bodyPr/>
@@ -12470,7 +12491,7 @@
                         <a:buNone/>
                       </a:pPr>
                       <a:r>
-                        <a:rPr lang="en-US" sz="1100" b="1" dirty="0">
+                        <a:rPr lang="en-US" sz="1200" b="1" dirty="0">
                           <a:solidFill>
                             <a:srgbClr val="1E2761"/>
                           </a:solidFill>
@@ -12480,7 +12501,7 @@
                         </a:rPr>
                         <a:t>TOUCHPOINTS</a:t>
                       </a:r>
-                      <a:endParaRPr lang="en-US" sz="1100" dirty="0">
+                      <a:endParaRPr lang="en-US" sz="1200" dirty="0">
                         <a:latin typeface="TH Sarabun New" charset="0"/>
                         <a:ea typeface="TH Sarabun New" charset="0"/>
                         <a:cs typeface="TH Sarabun New" charset="0"/>
@@ -12538,17 +12559,17 @@
                         <a:buNone/>
                       </a:pPr>
                       <a:r>
-                        <a:rPr lang="en-US" sz="1050" dirty="0">
+                        <a:rPr lang="en-US" sz="1250" dirty="0">
                           <a:solidFill>
-                            <a:srgbClr val="5B6B8C"/>
+                            <a:srgbClr val="1E2761"/>
                           </a:solidFill>
                           <a:latin typeface="TH Sarabun New" pitchFamily="34" charset="0"/>
                           <a:ea typeface="TH Sarabun New" pitchFamily="34" charset="-122"/>
                           <a:cs typeface="TH Sarabun New" pitchFamily="34" charset="-120"/>
                         </a:rPr>
-                        <a:t>เว็บ / แคตตาล็อก · ใบสั่งซื้อ</a:t>
+                        <a:t>เว็บ · ใบสั่งซื้อ</a:t>
                       </a:r>
-                      <a:endParaRPr lang="en-US" sz="1050" dirty="0">
+                      <a:endParaRPr lang="en-US" sz="1250" dirty="0">
                         <a:latin typeface="TH Sarabun New" charset="0"/>
                         <a:ea typeface="TH Sarabun New" charset="0"/>
                         <a:cs typeface="TH Sarabun New" charset="0"/>
@@ -12606,9 +12627,9 @@
                         <a:buNone/>
                       </a:pPr>
                       <a:r>
-                        <a:rPr lang="en-US" sz="1050" dirty="0">
+                        <a:rPr lang="en-US" sz="1250" dirty="0">
                           <a:solidFill>
-                            <a:srgbClr val="5B6B8C"/>
+                            <a:srgbClr val="1E2761"/>
                           </a:solidFill>
                           <a:latin typeface="TH Sarabun New" pitchFamily="34" charset="0"/>
                           <a:ea typeface="TH Sarabun New" pitchFamily="34" charset="-122"/>
@@ -12616,7 +12637,7 @@
                         </a:rPr>
                         <a:t>พัสดุ · POSTAGE</a:t>
                       </a:r>
-                      <a:endParaRPr lang="en-US" sz="1050" dirty="0">
+                      <a:endParaRPr lang="en-US" sz="1250" dirty="0">
                         <a:latin typeface="TH Sarabun New" charset="0"/>
                         <a:ea typeface="TH Sarabun New" charset="0"/>
                         <a:cs typeface="TH Sarabun New" charset="0"/>
@@ -12674,9 +12695,9 @@
                         <a:buNone/>
                       </a:pPr>
                       <a:r>
-                        <a:rPr lang="en-US" sz="1050" dirty="0">
+                        <a:rPr lang="en-US" sz="1250" dirty="0">
                           <a:solidFill>
-                            <a:srgbClr val="5B6B8C"/>
+                            <a:srgbClr val="1E2761"/>
                           </a:solidFill>
                           <a:latin typeface="TH Sarabun New" pitchFamily="34" charset="0"/>
                           <a:ea typeface="TH Sarabun New" pitchFamily="34" charset="-122"/>
@@ -12684,7 +12705,7 @@
                         </a:rPr>
                         <a:t>ใบสั่งซื้อรอบใหม่</a:t>
                       </a:r>
-                      <a:endParaRPr lang="en-US" sz="1050" dirty="0">
+                      <a:endParaRPr lang="en-US" sz="1250" dirty="0">
                         <a:latin typeface="TH Sarabun New" charset="0"/>
                         <a:ea typeface="TH Sarabun New" charset="0"/>
                         <a:cs typeface="TH Sarabun New" charset="0"/>
@@ -12742,9 +12763,9 @@
                         <a:buNone/>
                       </a:pPr>
                       <a:r>
-                        <a:rPr lang="en-US" sz="1050" dirty="0">
+                        <a:rPr lang="en-US" sz="1250" dirty="0">
                           <a:solidFill>
-                            <a:srgbClr val="5B6B8C"/>
+                            <a:srgbClr val="1E2761"/>
                           </a:solidFill>
                           <a:latin typeface="TH Sarabun New" pitchFamily="34" charset="0"/>
                           <a:ea typeface="TH Sarabun New" pitchFamily="34" charset="-122"/>
@@ -12752,7 +12773,7 @@
                         </a:rPr>
                         <a:t>ใบลดหนี้ (Invoice C)</a:t>
                       </a:r>
-                      <a:endParaRPr lang="en-US" sz="1050" dirty="0">
+                      <a:endParaRPr lang="en-US" sz="1250" dirty="0">
                         <a:latin typeface="TH Sarabun New" charset="0"/>
                         <a:ea typeface="TH Sarabun New" charset="0"/>
                         <a:cs typeface="TH Sarabun New" charset="0"/>
@@ -12810,7 +12831,7 @@
                         <a:buNone/>
                       </a:pPr>
                       <a:r>
-                        <a:rPr lang="en-US" sz="1050" dirty="0">
+                        <a:rPr lang="en-US" sz="1250" dirty="0">
                           <a:solidFill>
                             <a:srgbClr val="B3402F"/>
                           </a:solidFill>
@@ -12818,9 +12839,9 @@
                           <a:ea typeface="TH Sarabun New" pitchFamily="34" charset="-122"/>
                           <a:cs typeface="TH Sarabun New" pitchFamily="34" charset="-120"/>
                         </a:rPr>
-                        <a:t>❌ ไม่มี touchpoint ใด ๆ</a:t>
+                        <a:t>ไม่มีเลย</a:t>
                       </a:r>
-                      <a:endParaRPr lang="en-US" sz="1050" dirty="0">
+                      <a:endParaRPr lang="en-US" sz="1250" dirty="0">
                         <a:latin typeface="TH Sarabun New" charset="0"/>
                         <a:ea typeface="TH Sarabun New" charset="0"/>
                         <a:cs typeface="TH Sarabun New" charset="0"/>
@@ -12870,7 +12891,7 @@
                   </a:tcPr>
                 </a:tc>
               </a:tr>
-              <a:tr h="561703">
+              <a:tr h="566928">
                 <a:tc>
                   <a:txBody>
                     <a:bodyPr/>
@@ -12880,7 +12901,7 @@
                         <a:buNone/>
                       </a:pPr>
                       <a:r>
-                        <a:rPr lang="en-US" sz="1100" b="1" dirty="0">
+                        <a:rPr lang="en-US" sz="1200" b="1" dirty="0">
                           <a:solidFill>
                             <a:srgbClr val="1E2761"/>
                           </a:solidFill>
@@ -12890,7 +12911,7 @@
                         </a:rPr>
                         <a:t>ACTORS</a:t>
                       </a:r>
-                      <a:endParaRPr lang="en-US" sz="1100" dirty="0">
+                      <a:endParaRPr lang="en-US" sz="1200" dirty="0">
                         <a:latin typeface="TH Sarabun New" charset="0"/>
                         <a:ea typeface="TH Sarabun New" charset="0"/>
                         <a:cs typeface="TH Sarabun New" charset="0"/>
@@ -12948,9 +12969,9 @@
                         <a:buNone/>
                       </a:pPr>
                       <a:r>
-                        <a:rPr lang="en-US" sz="1050" dirty="0">
+                        <a:rPr lang="en-US" sz="1250" dirty="0">
                           <a:solidFill>
-                            <a:srgbClr val="5B6B8C"/>
+                            <a:srgbClr val="1E2761"/>
                           </a:solidFill>
                           <a:latin typeface="TH Sarabun New" pitchFamily="34" charset="0"/>
                           <a:ea typeface="TH Sarabun New" pitchFamily="34" charset="-122"/>
@@ -12958,7 +12979,7 @@
                         </a:rPr>
                         <a:t>ลูกค้า · ฝ่ายขาย</a:t>
                       </a:r>
-                      <a:endParaRPr lang="en-US" sz="1050" dirty="0">
+                      <a:endParaRPr lang="en-US" sz="1250" dirty="0">
                         <a:latin typeface="TH Sarabun New" charset="0"/>
                         <a:ea typeface="TH Sarabun New" charset="0"/>
                         <a:cs typeface="TH Sarabun New" charset="0"/>
@@ -13016,9 +13037,9 @@
                         <a:buNone/>
                       </a:pPr>
                       <a:r>
-                        <a:rPr lang="en-US" sz="1050" dirty="0">
+                        <a:rPr lang="en-US" sz="1250" dirty="0">
                           <a:solidFill>
-                            <a:srgbClr val="5B6B8C"/>
+                            <a:srgbClr val="1E2761"/>
                           </a:solidFill>
                           <a:latin typeface="TH Sarabun New" pitchFamily="34" charset="0"/>
                           <a:ea typeface="TH Sarabun New" pitchFamily="34" charset="-122"/>
@@ -13026,7 +13047,7 @@
                         </a:rPr>
                         <a:t>ขนส่ง · คลัง</a:t>
                       </a:r>
-                      <a:endParaRPr lang="en-US" sz="1050" dirty="0">
+                      <a:endParaRPr lang="en-US" sz="1250" dirty="0">
                         <a:latin typeface="TH Sarabun New" charset="0"/>
                         <a:ea typeface="TH Sarabun New" charset="0"/>
                         <a:cs typeface="TH Sarabun New" charset="0"/>
@@ -13084,9 +13105,9 @@
                         <a:buNone/>
                       </a:pPr>
                       <a:r>
-                        <a:rPr lang="en-US" sz="1050" dirty="0">
+                        <a:rPr lang="en-US" sz="1250" dirty="0">
                           <a:solidFill>
-                            <a:srgbClr val="5B6B8C"/>
+                            <a:srgbClr val="1E2761"/>
                           </a:solidFill>
                           <a:latin typeface="TH Sarabun New" pitchFamily="34" charset="0"/>
                           <a:ea typeface="TH Sarabun New" pitchFamily="34" charset="-122"/>
@@ -13094,7 +13115,7 @@
                         </a:rPr>
                         <a:t>ลูกค้า · ฝ่ายขาย</a:t>
                       </a:r>
-                      <a:endParaRPr lang="en-US" sz="1050" dirty="0">
+                      <a:endParaRPr lang="en-US" sz="1250" dirty="0">
                         <a:latin typeface="TH Sarabun New" charset="0"/>
                         <a:ea typeface="TH Sarabun New" charset="0"/>
                         <a:cs typeface="TH Sarabun New" charset="0"/>
@@ -13152,9 +13173,9 @@
                         <a:buNone/>
                       </a:pPr>
                       <a:r>
-                        <a:rPr lang="en-US" sz="1050" dirty="0">
+                        <a:rPr lang="en-US" sz="1250" dirty="0">
                           <a:solidFill>
-                            <a:srgbClr val="5B6B8C"/>
+                            <a:srgbClr val="1E2761"/>
                           </a:solidFill>
                           <a:latin typeface="TH Sarabun New" pitchFamily="34" charset="0"/>
                           <a:ea typeface="TH Sarabun New" pitchFamily="34" charset="-122"/>
@@ -13162,7 +13183,7 @@
                         </a:rPr>
                         <a:t>ฝ่ายบริการ · บัญชี</a:t>
                       </a:r>
-                      <a:endParaRPr lang="en-US" sz="1050" dirty="0">
+                      <a:endParaRPr lang="en-US" sz="1250" dirty="0">
                         <a:latin typeface="TH Sarabun New" charset="0"/>
                         <a:ea typeface="TH Sarabun New" charset="0"/>
                         <a:cs typeface="TH Sarabun New" charset="0"/>
@@ -13220,7 +13241,7 @@
                         <a:buNone/>
                       </a:pPr>
                       <a:r>
-                        <a:rPr lang="en-US" sz="1050" dirty="0">
+                        <a:rPr lang="en-US" sz="1250" dirty="0">
                           <a:solidFill>
                             <a:srgbClr val="B3402F"/>
                           </a:solidFill>
@@ -13228,9 +13249,9 @@
                           <a:ea typeface="TH Sarabun New" pitchFamily="34" charset="-122"/>
                           <a:cs typeface="TH Sarabun New" pitchFamily="34" charset="-120"/>
                         </a:rPr>
-                        <a:t>— ไม่มีใครรับผิดชอบ</a:t>
+                        <a:t>ไม่มีใครรับผิดชอบ</a:t>
                       </a:r>
-                      <a:endParaRPr lang="en-US" sz="1050" dirty="0">
+                      <a:endParaRPr lang="en-US" sz="1250" dirty="0">
                         <a:latin typeface="TH Sarabun New" charset="0"/>
                         <a:ea typeface="TH Sarabun New" charset="0"/>
                         <a:cs typeface="TH Sarabun New" charset="0"/>
@@ -13280,7 +13301,7 @@
                   </a:tcPr>
                 </a:tc>
               </a:tr>
-              <a:tr h="561703">
+              <a:tr h="566928">
                 <a:tc>
                   <a:txBody>
                     <a:bodyPr/>
@@ -13290,7 +13311,7 @@
                         <a:buNone/>
                       </a:pPr>
                       <a:r>
-                        <a:rPr lang="en-US" sz="1100" b="1" dirty="0">
+                        <a:rPr lang="en-US" sz="1200" b="1" dirty="0">
                           <a:solidFill>
                             <a:srgbClr val="1E2761"/>
                           </a:solidFill>
@@ -13300,7 +13321,7 @@
                         </a:rPr>
                         <a:t>EMOTIONS</a:t>
                       </a:r>
-                      <a:endParaRPr lang="en-US" sz="1100" dirty="0">
+                      <a:endParaRPr lang="en-US" sz="1200" dirty="0">
                         <a:latin typeface="TH Sarabun New" charset="0"/>
                         <a:ea typeface="TH Sarabun New" charset="0"/>
                         <a:cs typeface="TH Sarabun New" charset="0"/>
@@ -13358,17 +13379,17 @@
                         <a:buNone/>
                       </a:pPr>
                       <a:r>
-                        <a:rPr lang="en-US" sz="1050" dirty="0">
+                        <a:rPr lang="en-US" sz="1250" dirty="0">
                           <a:solidFill>
-                            <a:srgbClr val="5B6B8C"/>
+                            <a:srgbClr val="1E2761"/>
                           </a:solidFill>
                           <a:latin typeface="TH Sarabun New" pitchFamily="34" charset="0"/>
                           <a:ea typeface="TH Sarabun New" pitchFamily="34" charset="-122"/>
                           <a:cs typeface="TH Sarabun New" pitchFamily="34" charset="-120"/>
                         </a:rPr>
-                        <a:t>🙂 สนใจ</a:t>
+                        <a:t>สนใจ (+)</a:t>
                       </a:r>
-                      <a:endParaRPr lang="en-US" sz="1050" dirty="0">
+                      <a:endParaRPr lang="en-US" sz="1250" dirty="0">
                         <a:latin typeface="TH Sarabun New" charset="0"/>
                         <a:ea typeface="TH Sarabun New" charset="0"/>
                         <a:cs typeface="TH Sarabun New" charset="0"/>
@@ -13426,17 +13447,17 @@
                         <a:buNone/>
                       </a:pPr>
                       <a:r>
-                        <a:rPr lang="en-US" sz="1050" dirty="0">
+                        <a:rPr lang="en-US" sz="1250" dirty="0">
                           <a:solidFill>
-                            <a:srgbClr val="5B6B8C"/>
+                            <a:srgbClr val="1E2761"/>
                           </a:solidFill>
                           <a:latin typeface="TH Sarabun New" pitchFamily="34" charset="0"/>
                           <a:ea typeface="TH Sarabun New" pitchFamily="34" charset="-122"/>
                           <a:cs typeface="TH Sarabun New" pitchFamily="34" charset="-120"/>
                         </a:rPr>
-                        <a:t>😐 เฉย ๆ / 🙁 ถ้าของมีปัญหา</a:t>
+                        <a:t>เฉย ๆ (0)</a:t>
                       </a:r>
-                      <a:endParaRPr lang="en-US" sz="1050" dirty="0">
+                      <a:endParaRPr lang="en-US" sz="1250" dirty="0">
                         <a:latin typeface="TH Sarabun New" charset="0"/>
                         <a:ea typeface="TH Sarabun New" charset="0"/>
                         <a:cs typeface="TH Sarabun New" charset="0"/>
@@ -13494,17 +13515,17 @@
                         <a:buNone/>
                       </a:pPr>
                       <a:r>
-                        <a:rPr lang="en-US" sz="1050" dirty="0">
+                        <a:rPr lang="en-US" sz="1250" dirty="0">
                           <a:solidFill>
-                            <a:srgbClr val="5B6B8C"/>
+                            <a:srgbClr val="1E2761"/>
                           </a:solidFill>
                           <a:latin typeface="TH Sarabun New" pitchFamily="34" charset="0"/>
                           <a:ea typeface="TH Sarabun New" pitchFamily="34" charset="-122"/>
                           <a:cs typeface="TH Sarabun New" pitchFamily="34" charset="-120"/>
                         </a:rPr>
-                        <a:t>🙂 พอใจ</a:t>
+                        <a:t>พอใจ (+)</a:t>
                       </a:r>
-                      <a:endParaRPr lang="en-US" sz="1050" dirty="0">
+                      <a:endParaRPr lang="en-US" sz="1250" dirty="0">
                         <a:latin typeface="TH Sarabun New" charset="0"/>
                         <a:ea typeface="TH Sarabun New" charset="0"/>
                         <a:cs typeface="TH Sarabun New" charset="0"/>
@@ -13562,17 +13583,17 @@
                         <a:buNone/>
                       </a:pPr>
                       <a:r>
-                        <a:rPr lang="en-US" sz="1050" dirty="0">
+                        <a:rPr lang="en-US" sz="1250" dirty="0">
                           <a:solidFill>
-                            <a:srgbClr val="5B6B8C"/>
+                            <a:srgbClr val="1E2761"/>
                           </a:solidFill>
                           <a:latin typeface="TH Sarabun New" pitchFamily="34" charset="0"/>
                           <a:ea typeface="TH Sarabun New" pitchFamily="34" charset="-122"/>
                           <a:cs typeface="TH Sarabun New" pitchFamily="34" charset="-120"/>
                         </a:rPr>
-                        <a:t>😠 หงุดหงิด → 🙂 ถ้าแก้ได้</a:t>
+                        <a:t>หงุดหงิด (-)</a:t>
                       </a:r>
-                      <a:endParaRPr lang="en-US" sz="1050" dirty="0">
+                      <a:endParaRPr lang="en-US" sz="1250" dirty="0">
                         <a:latin typeface="TH Sarabun New" charset="0"/>
                         <a:ea typeface="TH Sarabun New" charset="0"/>
                         <a:cs typeface="TH Sarabun New" charset="0"/>
@@ -13630,7 +13651,7 @@
                         <a:buNone/>
                       </a:pPr>
                       <a:r>
-                        <a:rPr lang="en-US" sz="1050" dirty="0">
+                        <a:rPr lang="en-US" sz="1250" dirty="0">
                           <a:solidFill>
                             <a:srgbClr val="B3402F"/>
                           </a:solidFill>
@@ -13638,9 +13659,9 @@
                           <a:ea typeface="TH Sarabun New" pitchFamily="34" charset="-122"/>
                           <a:cs typeface="TH Sarabun New" pitchFamily="34" charset="-120"/>
                         </a:rPr>
-                        <a:t>😶 เฉยชา แล้วหายไป</a:t>
+                        <a:t>เฉยชา แล้วหายไป (-)</a:t>
                       </a:r>
-                      <a:endParaRPr lang="en-US" sz="1050" dirty="0">
+                      <a:endParaRPr lang="en-US" sz="1250" dirty="0">
                         <a:latin typeface="TH Sarabun New" charset="0"/>
                         <a:ea typeface="TH Sarabun New" charset="0"/>
                         <a:cs typeface="TH Sarabun New" charset="0"/>
@@ -13690,7 +13711,7 @@
                   </a:tcPr>
                 </a:tc>
               </a:tr>
-              <a:tr h="561703">
+              <a:tr h="566928">
                 <a:tc>
                   <a:txBody>
                     <a:bodyPr/>
@@ -13700,7 +13721,7 @@
                         <a:buNone/>
                       </a:pPr>
                       <a:r>
-                        <a:rPr lang="en-US" sz="1100" b="1" dirty="0">
+                        <a:rPr lang="en-US" sz="1200" b="1" dirty="0">
                           <a:solidFill>
                             <a:srgbClr val="1E2761"/>
                           </a:solidFill>
@@ -13708,9 +13729,9 @@
                           <a:ea typeface="TH Sarabun New" pitchFamily="34" charset="-122"/>
                           <a:cs typeface="TH Sarabun New" pitchFamily="34" charset="-120"/>
                         </a:rPr>
-                        <a:t>📉 ที่หลุด</a:t>
+                        <a:t>ที่หลุด</a:t>
                       </a:r>
-                      <a:endParaRPr lang="en-US" sz="1100" dirty="0">
+                      <a:endParaRPr lang="en-US" sz="1200" dirty="0">
                         <a:latin typeface="TH Sarabun New" charset="0"/>
                         <a:ea typeface="TH Sarabun New" charset="0"/>
                         <a:cs typeface="TH Sarabun New" charset="0"/>
@@ -13768,17 +13789,38 @@
                         <a:buNone/>
                       </a:pPr>
                       <a:r>
-                        <a:rPr lang="en-US" sz="1050" dirty="0">
+                        <a:rPr lang="en-US" sz="1250" dirty="0">
                           <a:solidFill>
-                            <a:srgbClr val="5B6B8C"/>
+                            <a:srgbClr val="1E2761"/>
                           </a:solidFill>
                           <a:latin typeface="TH Sarabun New" pitchFamily="34" charset="0"/>
                           <a:ea typeface="TH Sarabun New" pitchFamily="34" charset="-122"/>
                           <a:cs typeface="TH Sarabun New" pitchFamily="34" charset="-120"/>
                         </a:rPr>
-                        <a:t>ลูกค้าที่มี ID 5,852 ราย</a:t>
+                        <a:t>ลูกค้าที่มี ID</a:t>
                       </a:r>
-                      <a:endParaRPr lang="en-US" sz="1050" dirty="0">
+                      <a:endParaRPr lang="en-US" sz="1250" dirty="0">
+                        <a:latin typeface="TH Sarabun New" charset="0"/>
+                        <a:ea typeface="TH Sarabun New" charset="0"/>
+                        <a:cs typeface="TH Sarabun New" charset="0"/>
+                      </a:endParaRPr>
+                    </a:p>
+                    <a:p>
+                      <a:pPr indent="0" marL="0">
+                        <a:buNone/>
+                      </a:pPr>
+                      <a:r>
+                        <a:rPr lang="en-US" sz="1250" dirty="0">
+                          <a:solidFill>
+                            <a:srgbClr val="1E2761"/>
+                          </a:solidFill>
+                          <a:latin typeface="TH Sarabun New" pitchFamily="34" charset="0"/>
+                          <a:ea typeface="TH Sarabun New" pitchFamily="34" charset="-122"/>
+                          <a:cs typeface="TH Sarabun New" pitchFamily="34" charset="-120"/>
+                        </a:rPr>
+                        <a:t>5,852 ราย</a:t>
+                      </a:r>
+                      <a:endParaRPr lang="en-US" sz="1250" dirty="0">
                         <a:latin typeface="TH Sarabun New" charset="0"/>
                         <a:ea typeface="TH Sarabun New" charset="0"/>
                         <a:cs typeface="TH Sarabun New" charset="0"/>
@@ -13836,7 +13878,7 @@
                         <a:buNone/>
                       </a:pPr>
                       <a:r>
-                        <a:rPr lang="en-US" sz="1050" dirty="0">
+                        <a:rPr lang="en-US" sz="1250" dirty="0">
                           <a:solidFill>
                             <a:srgbClr val="5B6B8C"/>
                           </a:solidFill>
@@ -13846,7 +13888,7 @@
                         </a:rPr>
                         <a:t>—</a:t>
                       </a:r>
-                      <a:endParaRPr lang="en-US" sz="1050" dirty="0">
+                      <a:endParaRPr lang="en-US" sz="1250" dirty="0">
                         <a:latin typeface="TH Sarabun New" charset="0"/>
                         <a:ea typeface="TH Sarabun New" charset="0"/>
                         <a:cs typeface="TH Sarabun New" charset="0"/>
@@ -13904,7 +13946,7 @@
                         <a:buNone/>
                       </a:pPr>
                       <a:r>
-                        <a:rPr lang="en-US" sz="1050" b="1" dirty="0">
+                        <a:rPr lang="en-US" sz="1250" b="1" dirty="0">
                           <a:solidFill>
                             <a:srgbClr val="B3402F"/>
                           </a:solidFill>
@@ -13912,9 +13954,30 @@
                           <a:ea typeface="TH Sarabun New" pitchFamily="34" charset="-122"/>
                           <a:cs typeface="TH Sarabun New" pitchFamily="34" charset="-120"/>
                         </a:rPr>
-                        <a:t>หลุด 1,618 ราย (27.65%) ไม่กลับมาเลย · cohort ยืนยัน 24.79%</a:t>
+                        <a:t>หลุด 1,618 ราย</a:t>
                       </a:r>
-                      <a:endParaRPr lang="en-US" sz="1050" dirty="0">
+                      <a:endParaRPr lang="en-US" sz="1250" dirty="0">
+                        <a:latin typeface="TH Sarabun New" charset="0"/>
+                        <a:ea typeface="TH Sarabun New" charset="0"/>
+                        <a:cs typeface="TH Sarabun New" charset="0"/>
+                      </a:endParaRPr>
+                    </a:p>
+                    <a:p>
+                      <a:pPr indent="0" marL="0">
+                        <a:buNone/>
+                      </a:pPr>
+                      <a:r>
+                        <a:rPr lang="en-US" sz="1250" b="1" dirty="0">
+                          <a:solidFill>
+                            <a:srgbClr val="B3402F"/>
+                          </a:solidFill>
+                          <a:latin typeface="TH Sarabun New" pitchFamily="34" charset="0"/>
+                          <a:ea typeface="TH Sarabun New" pitchFamily="34" charset="-122"/>
+                          <a:cs typeface="TH Sarabun New" pitchFamily="34" charset="-120"/>
+                        </a:rPr>
+                        <a:t>(27.65%)</a:t>
+                      </a:r>
+                      <a:endParaRPr lang="en-US" sz="1250" dirty="0">
                         <a:latin typeface="TH Sarabun New" charset="0"/>
                         <a:ea typeface="TH Sarabun New" charset="0"/>
                         <a:cs typeface="TH Sarabun New" charset="0"/>
@@ -13972,7 +14035,7 @@
                         <a:buNone/>
                       </a:pPr>
                       <a:r>
-                        <a:rPr lang="en-US" sz="1050" dirty="0">
+                        <a:rPr lang="en-US" sz="1250" dirty="0">
                           <a:solidFill>
                             <a:srgbClr val="1E2761"/>
                           </a:solidFill>
@@ -13980,9 +14043,30 @@
                           <a:ea typeface="TH Sarabun New" pitchFamily="34" charset="-122"/>
                           <a:cs typeface="TH Sarabun New" pitchFamily="34" charset="-120"/>
                         </a:rPr>
-                        <a:t>2,496 ราย (42.65%) เคยคืนของ · คืนสินค้าจริง £726,589 (3.61%)</a:t>
+                        <a:t>2,496 ราย (42.65%)</a:t>
                       </a:r>
-                      <a:endParaRPr lang="en-US" sz="1050" dirty="0">
+                      <a:endParaRPr lang="en-US" sz="1250" dirty="0">
+                        <a:latin typeface="TH Sarabun New" charset="0"/>
+                        <a:ea typeface="TH Sarabun New" charset="0"/>
+                        <a:cs typeface="TH Sarabun New" charset="0"/>
+                      </a:endParaRPr>
+                    </a:p>
+                    <a:p>
+                      <a:pPr indent="0" marL="0">
+                        <a:buNone/>
+                      </a:pPr>
+                      <a:r>
+                        <a:rPr lang="en-US" sz="1250" dirty="0">
+                          <a:solidFill>
+                            <a:srgbClr val="1E2761"/>
+                          </a:solidFill>
+                          <a:latin typeface="TH Sarabun New" pitchFamily="34" charset="0"/>
+                          <a:ea typeface="TH Sarabun New" pitchFamily="34" charset="-122"/>
+                          <a:cs typeface="TH Sarabun New" pitchFamily="34" charset="-120"/>
+                        </a:rPr>
+                        <a:t>เคยคืนของ</a:t>
+                      </a:r>
+                      <a:endParaRPr lang="en-US" sz="1250" dirty="0">
                         <a:latin typeface="TH Sarabun New" charset="0"/>
                         <a:ea typeface="TH Sarabun New" charset="0"/>
                         <a:cs typeface="TH Sarabun New" charset="0"/>
@@ -14040,7 +14124,7 @@
                         <a:buNone/>
                       </a:pPr>
                       <a:r>
-                        <a:rPr lang="en-US" sz="1050" b="1" dirty="0">
+                        <a:rPr lang="en-US" sz="1250" b="1" dirty="0">
                           <a:solidFill>
                             <a:srgbClr val="B3402F"/>
                           </a:solidFill>
@@ -14048,9 +14132,30 @@
                           <a:ea typeface="TH Sarabun New" pitchFamily="34" charset="-122"/>
                           <a:cs typeface="TH Sarabun New" pitchFamily="34" charset="-120"/>
                         </a:rPr>
-                        <a:t>2,378 ราย (40.64%) เงียบเกิน 180 วัน = 13.49% ของยอดขาย</a:t>
+                        <a:t>2,378 ราย (40.64%)</a:t>
                       </a:r>
-                      <a:endParaRPr lang="en-US" sz="1050" dirty="0">
+                      <a:endParaRPr lang="en-US" sz="1250" dirty="0">
+                        <a:latin typeface="TH Sarabun New" charset="0"/>
+                        <a:ea typeface="TH Sarabun New" charset="0"/>
+                        <a:cs typeface="TH Sarabun New" charset="0"/>
+                      </a:endParaRPr>
+                    </a:p>
+                    <a:p>
+                      <a:pPr indent="0" marL="0">
+                        <a:buNone/>
+                      </a:pPr>
+                      <a:r>
+                        <a:rPr lang="en-US" sz="1250" b="1" dirty="0">
+                          <a:solidFill>
+                            <a:srgbClr val="B3402F"/>
+                          </a:solidFill>
+                          <a:latin typeface="TH Sarabun New" pitchFamily="34" charset="0"/>
+                          <a:ea typeface="TH Sarabun New" pitchFamily="34" charset="-122"/>
+                          <a:cs typeface="TH Sarabun New" pitchFamily="34" charset="-120"/>
+                        </a:rPr>
+                        <a:t>เงียบเกิน 180 วัน</a:t>
+                      </a:r>
+                      <a:endParaRPr lang="en-US" sz="1250" dirty="0">
                         <a:latin typeface="TH Sarabun New" charset="0"/>
                         <a:ea typeface="TH Sarabun New" charset="0"/>
                         <a:cs typeface="TH Sarabun New" charset="0"/>
@@ -14112,12 +14217,12 @@
         </p:nvSpPr>
         <p:spPr>
           <a:xfrm>
-            <a:off x="411480" y="5532120"/>
-            <a:ext cx="11384280" cy="777240"/>
+            <a:off x="411480" y="5577840"/>
+            <a:ext cx="11384280" cy="731520"/>
           </a:xfrm>
           <a:prstGeom prst="roundRect">
             <a:avLst>
-              <a:gd name="adj" fmla="val 9412"/>
+              <a:gd name="adj" fmla="val 10000"/>
             </a:avLst>
           </a:prstGeom>
           <a:solidFill>
@@ -14139,8 +14244,8 @@
         </p:nvSpPr>
         <p:spPr>
           <a:xfrm>
-            <a:off x="612648" y="5532120"/>
-            <a:ext cx="10981944" cy="777240"/>
+            <a:off x="612648" y="5577840"/>
+            <a:ext cx="10981944" cy="731520"/>
           </a:xfrm>
           <a:prstGeom prst="rect">
             <a:avLst/>
@@ -14167,7 +14272,7 @@
                 <a:ea typeface="TH Sarabun New" pitchFamily="34" charset="-122"/>
                 <a:cs typeface="TH Sarabun New" pitchFamily="34" charset="-120"/>
               </a:rPr>
-              <a:t>จุดที่คนหลุดมากที่สุด: stage 2 → 3 </a:t>
+              <a:t>หลุดมากที่สุด: stage 2 → 3 </a:t>
             </a:r>
             <a:pPr indent="0" marL="0">
               <a:lnSpc>
@@ -14184,7 +14289,7 @@
                 <a:ea typeface="TH Sarabun New" pitchFamily="34" charset="-122"/>
                 <a:cs typeface="TH Sarabun New" pitchFamily="34" charset="-120"/>
               </a:rPr>
-              <a:t>(รับของครั้งแรกแล้วไม่กลับมา 1,618 ราย)  ·  </a:t>
+              <a:t>(รับของครั้งแรกแล้วไม่กลับมา 1,618 ราย)   ·   </a:t>
             </a:r>
             <a:pPr indent="0" marL="0">
               <a:lnSpc>
@@ -14201,7 +14306,7 @@
                 <a:ea typeface="TH Sarabun New" pitchFamily="34" charset="-122"/>
                 <a:cs typeface="TH Sarabun New" pitchFamily="34" charset="-120"/>
               </a:rPr>
-              <a:t>จุดที่แพงที่สุด: stage 5 </a:t>
+              <a:t>แพงที่สุด: stage 5 </a:t>
             </a:r>
             <a:pPr indent="0" marL="0">
               <a:lnSpc>
@@ -14218,7 +14323,7 @@
                 <a:ea typeface="TH Sarabun New" pitchFamily="34" charset="-122"/>
                 <a:cs typeface="TH Sarabun New" pitchFamily="34" charset="-120"/>
               </a:rPr>
-              <a:t>ซึ่งไม่มี touchpoint และไม่มี actor รับผิดชอบเลย — ตรงกับ feedback loop ที่ขาดใน B1</a:t>
+              <a:t>ซึ่งไม่มี touchpoint และไม่มีใครรับผิดชอบ — ตรงกับ feedback loop ที่ขาดใน B1</a:t>
             </a:r>
             <a:endParaRPr lang="en-US" sz="1350" dirty="0"/>
           </a:p>

</xml_diff>